<commit_message>
Execute Phase 5.1: Deck Integrity Hardening with dynamic safety configs and claim checks
</commit_message>
<xml_diff>
--- a/06_render/out/deck_exfoliants.pptx
+++ b/06_render/out/deck_exfoliants.pptx
@@ -5125,7 +5125,7 @@
                 </a:solidFill>
                 <a:latin typeface="Arimo"/>
               </a:rPr>
-              <a:t>Правила безопасности при проведении химических пилингов</a:t>
+              <a:t>Правила проведения химических пилингов и защита кожи</a:t>
             </a:r>
           </a:p>
         </p:txBody>
@@ -5260,7 +5260,7 @@
                 </a:solidFill>
                 <a:latin typeface="Arimo"/>
               </a:rPr>
-              <a:t>Меры предосторожности: Беременность, Лактация и Фотозащита</a:t>
+              <a:t>Меры предосторожности: УФ-защита</a:t>
             </a:r>
           </a:p>
         </p:txBody>
@@ -5305,7 +5305,7 @@
                 </a:solidFill>
                 <a:latin typeface="Arimo"/>
               </a:rPr>
-              <a:t>Клинические пилинги (салициловый 30%, гликолевый) требуют строгого SPF-сопровождения из-за риска фотосенсибилизации. Проведение высококонцентрированных процедур противопоказано при беременности и лактации.</a:t>
+              <a:t>Высококонцентрированные клинические пилинги (салициловый 30% и гликолевый) временно повышают чувствительность кожи к ультрафиолетовому излучению, требуя обязательного использования SPF-средств.</a:t>
             </a:r>
           </a:p>
         </p:txBody>

</xml_diff>

<commit_message>
Implement Phase 4.5: Visual Assets with dynamic molecule generation, pilot receptor mechanism diagrams, renderer updates, and hardened QA provenance checks
</commit_message>
<xml_diff>
--- a/06_render/out/deck_exfoliants.pptx
+++ b/06_render/out/deck_exfoliants.pptx
@@ -3220,7 +3220,7 @@
               </a:lnSpc>
               <a:defRPr sz="3600" b="1" i="0">
                 <a:solidFill>
-                  <a:srgbClr val="2C3440"/>
+                  <a:srgbClr val="1D291C"/>
                 </a:solidFill>
                 <a:latin typeface="Arimo"/>
               </a:defRPr>
@@ -3228,7 +3228,7 @@
             <a:r>
               <a:rPr sz="3600" b="1" i="0">
                 <a:solidFill>
-                  <a:srgbClr val="2C3440"/>
+                  <a:srgbClr val="1D291C"/>
                 </a:solidFill>
                 <a:latin typeface="Arimo"/>
               </a:rPr>
@@ -3338,7 +3338,7 @@
                 </a:solidFill>
                 <a:latin typeface="Arimo"/>
               </a:rPr>
-              <a:t>Применение кислот в дерматокосметологии</a:t>
+              <a:t>[Placeholder] Применение кислот в дерматокосметологии</a:t>
             </a:r>
           </a:p>
         </p:txBody>
@@ -3487,7 +3487,7 @@
               </a:lnSpc>
               <a:defRPr sz="3600" b="1" i="0">
                 <a:solidFill>
-                  <a:srgbClr val="2C3440"/>
+                  <a:srgbClr val="1D291C"/>
                 </a:solidFill>
                 <a:latin typeface="Arimo"/>
               </a:defRPr>
@@ -3495,7 +3495,7 @@
             <a:r>
               <a:rPr sz="3600" b="1" i="0">
                 <a:solidFill>
-                  <a:srgbClr val="2C3440"/>
+                  <a:srgbClr val="1D291C"/>
                 </a:solidFill>
                 <a:latin typeface="Arimo"/>
               </a:rPr>
@@ -3693,7 +3693,7 @@
               </a:lnSpc>
               <a:defRPr sz="2600" b="1" i="0">
                 <a:solidFill>
-                  <a:srgbClr val="2C3440"/>
+                  <a:srgbClr val="1D291C"/>
                 </a:solidFill>
                 <a:latin typeface="Arimo"/>
               </a:defRPr>
@@ -3701,7 +3701,7 @@
             <a:r>
               <a:rPr sz="2600" b="1" i="0">
                 <a:solidFill>
-                  <a:srgbClr val="2C3440"/>
+                  <a:srgbClr val="1D291C"/>
                 </a:solidFill>
                 <a:latin typeface="Arimo"/>
               </a:rPr>
@@ -3870,67 +3870,30 @@
           </a:p>
         </p:txBody>
       </p:sp>
-      <p:sp>
-        <p:nvSpPr>
-          <p:cNvPr id="7" name="Rounded Rectangle 6"/>
-          <p:cNvSpPr/>
+      <p:pic>
+        <p:nvPicPr>
+          <p:cNvPr id="7" name="Picture 6" descr="salicylic_acid.png"/>
+          <p:cNvPicPr>
+            <a:picLocks noChangeAspect="1"/>
+          </p:cNvPicPr>
           <p:nvPr/>
-        </p:nvSpPr>
+        </p:nvPicPr>
+        <p:blipFill>
+          <a:blip r:embed="rId2"/>
+          <a:stretch>
+            <a:fillRect/>
+          </a:stretch>
+        </p:blipFill>
         <p:spPr>
           <a:xfrm>
             <a:off x="5179218" y="1339453"/>
             <a:ext cx="3607593" cy="2857500"/>
           </a:xfrm>
-          <a:prstGeom prst="roundRect">
+          <a:prstGeom prst="rect">
             <a:avLst/>
           </a:prstGeom>
-          <a:solidFill>
-            <a:srgbClr val="D7E0CE"/>
-          </a:solidFill>
-          <a:ln w="12700">
-            <a:solidFill>
-              <a:srgbClr val="D7E0CE"/>
-            </a:solidFill>
-          </a:ln>
-        </p:spPr>
-        <p:style>
-          <a:lnRef idx="1">
-            <a:schemeClr val="accent1"/>
-          </a:lnRef>
-          <a:fillRef idx="3">
-            <a:schemeClr val="accent1"/>
-          </a:fillRef>
-          <a:effectRef idx="2">
-            <a:schemeClr val="accent1"/>
-          </a:effectRef>
-          <a:fontRef idx="minor">
-            <a:schemeClr val="lt1"/>
-          </a:fontRef>
-        </p:style>
-        <p:txBody>
-          <a:bodyPr rtlCol="0" anchor="ctr" wrap="square"/>
-          <a:lstStyle/>
-          <a:p>
-            <a:pPr algn="ctr">
-              <a:defRPr sz="1300" b="1">
-                <a:solidFill>
-                  <a:srgbClr val="6D8470"/>
-                </a:solidFill>
-                <a:latin typeface="Arimo"/>
-              </a:defRPr>
-            </a:pPr>
-            <a:r>
-              <a:rPr sz="1300" b="1">
-                <a:solidFill>
-                  <a:srgbClr val="6D8470"/>
-                </a:solidFill>
-                <a:latin typeface="Arimo"/>
-              </a:rPr>
-              <a:t>Липофильная BHA-эксфолиация и комедолиз</a:t>
-            </a:r>
-          </a:p>
-        </p:txBody>
-      </p:sp>
+        </p:spPr>
+      </p:pic>
     </p:spTree>
   </p:cSld>
   <p:clrMapOvr>
@@ -4075,7 +4038,7 @@
               </a:lnSpc>
               <a:defRPr sz="2600" b="1" i="0">
                 <a:solidFill>
-                  <a:srgbClr val="2C3440"/>
+                  <a:srgbClr val="1D291C"/>
                 </a:solidFill>
                 <a:latin typeface="Arimo"/>
               </a:defRPr>
@@ -4083,7 +4046,7 @@
             <a:r>
               <a:rPr sz="2600" b="1" i="0">
                 <a:solidFill>
-                  <a:srgbClr val="2C3440"/>
+                  <a:srgbClr val="1D291C"/>
                 </a:solidFill>
                 <a:latin typeface="Arimo"/>
               </a:rPr>
@@ -4210,7 +4173,7 @@
               </a:lnSpc>
               <a:defRPr sz="1800" b="1" i="0">
                 <a:solidFill>
-                  <a:srgbClr val="2C3440"/>
+                  <a:srgbClr val="1D291C"/>
                 </a:solidFill>
                 <a:latin typeface="Arimo"/>
               </a:defRPr>
@@ -4218,7 +4181,7 @@
             <a:r>
               <a:rPr sz="1800" b="1" i="0">
                 <a:solidFill>
-                  <a:srgbClr val="2C3440"/>
+                  <a:srgbClr val="1D291C"/>
                 </a:solidFill>
                 <a:latin typeface="Arimo"/>
               </a:rPr>
@@ -4345,7 +4308,7 @@
               </a:lnSpc>
               <a:defRPr sz="1800" b="1" i="0">
                 <a:solidFill>
-                  <a:srgbClr val="2C3440"/>
+                  <a:srgbClr val="1D291C"/>
                 </a:solidFill>
                 <a:latin typeface="Arimo"/>
               </a:defRPr>
@@ -4353,7 +4316,7 @@
             <a:r>
               <a:rPr sz="1800" b="1" i="0">
                 <a:solidFill>
-                  <a:srgbClr val="2C3440"/>
+                  <a:srgbClr val="1D291C"/>
                 </a:solidFill>
                 <a:latin typeface="Arimo"/>
               </a:rPr>
@@ -4480,7 +4443,7 @@
               </a:lnSpc>
               <a:defRPr sz="1800" b="1" i="0">
                 <a:solidFill>
-                  <a:srgbClr val="2C3440"/>
+                  <a:srgbClr val="1D291C"/>
                 </a:solidFill>
                 <a:latin typeface="Arimo"/>
               </a:defRPr>
@@ -4488,7 +4451,7 @@
             <a:r>
               <a:rPr sz="1800" b="1" i="0">
                 <a:solidFill>
-                  <a:srgbClr val="2C3440"/>
+                  <a:srgbClr val="1D291C"/>
                 </a:solidFill>
                 <a:latin typeface="Arimo"/>
               </a:rPr>
@@ -4686,7 +4649,7 @@
               </a:lnSpc>
               <a:defRPr sz="2600" b="1" i="0">
                 <a:solidFill>
-                  <a:srgbClr val="2C3440"/>
+                  <a:srgbClr val="1D291C"/>
                 </a:solidFill>
                 <a:latin typeface="Arimo"/>
               </a:defRPr>
@@ -4694,7 +4657,7 @@
             <a:r>
               <a:rPr sz="2600" b="1" i="0">
                 <a:solidFill>
-                  <a:srgbClr val="2C3440"/>
+                  <a:srgbClr val="1D291C"/>
                 </a:solidFill>
                 <a:latin typeface="Arimo"/>
               </a:rPr>
@@ -4919,7 +4882,7 @@
                 </a:solidFill>
                 <a:latin typeface="Arimo"/>
               </a:rPr>
-              <a:t>Динамика изменения толщины дермы после AHA-терапии</a:t>
+              <a:t>[Placeholder] Динамика изменения толщины дермы после AHA-терапии</a:t>
             </a:r>
           </a:p>
         </p:txBody>
@@ -5068,7 +5031,7 @@
               </a:lnSpc>
               <a:defRPr sz="2600" b="1" i="0">
                 <a:solidFill>
-                  <a:srgbClr val="2C3440"/>
+                  <a:srgbClr val="1D291C"/>
                 </a:solidFill>
                 <a:latin typeface="Arimo"/>
               </a:defRPr>
@@ -5076,7 +5039,7 @@
             <a:r>
               <a:rPr sz="2600" b="1" i="0">
                 <a:solidFill>
-                  <a:srgbClr val="2C3440"/>
+                  <a:srgbClr val="1D291C"/>
                 </a:solidFill>
                 <a:latin typeface="Arimo"/>
               </a:rPr>
@@ -5454,7 +5417,7 @@
               </a:lnSpc>
               <a:defRPr sz="2600" b="1" i="0">
                 <a:solidFill>
-                  <a:srgbClr val="2C3440"/>
+                  <a:srgbClr val="1D291C"/>
                 </a:solidFill>
                 <a:latin typeface="Arimo"/>
               </a:defRPr>
@@ -5462,7 +5425,7 @@
             <a:r>
               <a:rPr sz="2600" b="1" i="0">
                 <a:solidFill>
-                  <a:srgbClr val="2C3440"/>
+                  <a:srgbClr val="1D291C"/>
                 </a:solidFill>
                 <a:latin typeface="Arimo"/>
               </a:rPr>

</xml_diff>

<commit_message>
Implement Phase 4.5b: Mechanism Assets Rollout with brand-aligned vector diagrams for Vitamin C, Niacinamide, and Exfoliants
</commit_message>
<xml_diff>
--- a/06_render/out/deck_exfoliants.pptx
+++ b/06_render/out/deck_exfoliants.pptx
@@ -3220,7 +3220,7 @@
               </a:lnSpc>
               <a:defRPr sz="3600" b="1" i="0">
                 <a:solidFill>
-                  <a:srgbClr val="1D291C"/>
+                  <a:srgbClr val="2C3440"/>
                 </a:solidFill>
                 <a:latin typeface="Arimo"/>
               </a:defRPr>
@@ -3228,7 +3228,7 @@
             <a:r>
               <a:rPr sz="3600" b="1" i="0">
                 <a:solidFill>
-                  <a:srgbClr val="1D291C"/>
+                  <a:srgbClr val="2C3440"/>
                 </a:solidFill>
                 <a:latin typeface="Arimo"/>
               </a:rPr>
@@ -3487,7 +3487,7 @@
               </a:lnSpc>
               <a:defRPr sz="3600" b="1" i="0">
                 <a:solidFill>
-                  <a:srgbClr val="1D291C"/>
+                  <a:srgbClr val="2C3440"/>
                 </a:solidFill>
                 <a:latin typeface="Arimo"/>
               </a:defRPr>
@@ -3495,7 +3495,7 @@
             <a:r>
               <a:rPr sz="3600" b="1" i="0">
                 <a:solidFill>
-                  <a:srgbClr val="1D291C"/>
+                  <a:srgbClr val="2C3440"/>
                 </a:solidFill>
                 <a:latin typeface="Arimo"/>
               </a:rPr>
@@ -3615,7 +3615,7 @@
                 </a:solidFill>
                 <a:latin typeface="Arimo"/>
               </a:rPr>
-              <a:t>ТОЛЬКО ДЛЯ ПРАКТИКУЮЩИХ СПЕЦИАЛИСТОВ</a:t>
+              <a:t>ТОЛЬКО ДЛЯ ПРАКТИКУЮЩИХ СПЕЦИАЛИСТОВ | SERVIER MEDICAL ART BY LES LABORATOIRES SERVIER (CC-BY 4.0)</a:t>
             </a:r>
           </a:p>
         </p:txBody>
@@ -3693,7 +3693,7 @@
               </a:lnSpc>
               <a:defRPr sz="2600" b="1" i="0">
                 <a:solidFill>
-                  <a:srgbClr val="1D291C"/>
+                  <a:srgbClr val="2C3440"/>
                 </a:solidFill>
                 <a:latin typeface="Arimo"/>
               </a:defRPr>
@@ -3701,7 +3701,7 @@
             <a:r>
               <a:rPr sz="2600" b="1" i="0">
                 <a:solidFill>
-                  <a:srgbClr val="1D291C"/>
+                  <a:srgbClr val="2C3440"/>
                 </a:solidFill>
                 <a:latin typeface="Arimo"/>
               </a:rPr>
@@ -3872,7 +3872,7 @@
       </p:sp>
       <p:pic>
         <p:nvPicPr>
-          <p:cNvPr id="7" name="Picture 6" descr="salicylic_acid.png"/>
+          <p:cNvPr id="7" name="Picture 6" descr="desmosome_desmolysis.png"/>
           <p:cNvPicPr>
             <a:picLocks noChangeAspect="1"/>
           </p:cNvPicPr>
@@ -4038,7 +4038,7 @@
               </a:lnSpc>
               <a:defRPr sz="2600" b="1" i="0">
                 <a:solidFill>
-                  <a:srgbClr val="1D291C"/>
+                  <a:srgbClr val="2C3440"/>
                 </a:solidFill>
                 <a:latin typeface="Arimo"/>
               </a:defRPr>
@@ -4046,7 +4046,7 @@
             <a:r>
               <a:rPr sz="2600" b="1" i="0">
                 <a:solidFill>
-                  <a:srgbClr val="1D291C"/>
+                  <a:srgbClr val="2C3440"/>
                 </a:solidFill>
                 <a:latin typeface="Arimo"/>
               </a:rPr>
@@ -4173,7 +4173,7 @@
               </a:lnSpc>
               <a:defRPr sz="1800" b="1" i="0">
                 <a:solidFill>
-                  <a:srgbClr val="1D291C"/>
+                  <a:srgbClr val="2C3440"/>
                 </a:solidFill>
                 <a:latin typeface="Arimo"/>
               </a:defRPr>
@@ -4181,7 +4181,7 @@
             <a:r>
               <a:rPr sz="1800" b="1" i="0">
                 <a:solidFill>
-                  <a:srgbClr val="1D291C"/>
+                  <a:srgbClr val="2C3440"/>
                 </a:solidFill>
                 <a:latin typeface="Arimo"/>
               </a:rPr>
@@ -4308,7 +4308,7 @@
               </a:lnSpc>
               <a:defRPr sz="1800" b="1" i="0">
                 <a:solidFill>
-                  <a:srgbClr val="1D291C"/>
+                  <a:srgbClr val="2C3440"/>
                 </a:solidFill>
                 <a:latin typeface="Arimo"/>
               </a:defRPr>
@@ -4316,7 +4316,7 @@
             <a:r>
               <a:rPr sz="1800" b="1" i="0">
                 <a:solidFill>
-                  <a:srgbClr val="1D291C"/>
+                  <a:srgbClr val="2C3440"/>
                 </a:solidFill>
                 <a:latin typeface="Arimo"/>
               </a:rPr>
@@ -4443,7 +4443,7 @@
               </a:lnSpc>
               <a:defRPr sz="1800" b="1" i="0">
                 <a:solidFill>
-                  <a:srgbClr val="1D291C"/>
+                  <a:srgbClr val="2C3440"/>
                 </a:solidFill>
                 <a:latin typeface="Arimo"/>
               </a:defRPr>
@@ -4451,7 +4451,7 @@
             <a:r>
               <a:rPr sz="1800" b="1" i="0">
                 <a:solidFill>
-                  <a:srgbClr val="1D291C"/>
+                  <a:srgbClr val="2C3440"/>
                 </a:solidFill>
                 <a:latin typeface="Arimo"/>
               </a:rPr>
@@ -4571,7 +4571,7 @@
                 </a:solidFill>
                 <a:latin typeface="Arimo"/>
               </a:rPr>
-              <a:t>ТОЛЬКО ДЛЯ ПРАКТИКУЮЩИХ СПЕЦИАЛИСТОВ</a:t>
+              <a:t>ТОЛЬКО ДЛЯ ПРАКТИКУЮЩИХ СПЕЦИАЛИСТОВ | SERVIER MEDICAL ART BY LES LABORATOIRES SERVIER (CC-BY 4.0)</a:t>
             </a:r>
           </a:p>
         </p:txBody>
@@ -4649,7 +4649,7 @@
               </a:lnSpc>
               <a:defRPr sz="2600" b="1" i="0">
                 <a:solidFill>
-                  <a:srgbClr val="1D291C"/>
+                  <a:srgbClr val="2C3440"/>
                 </a:solidFill>
                 <a:latin typeface="Arimo"/>
               </a:defRPr>
@@ -4657,7 +4657,7 @@
             <a:r>
               <a:rPr sz="2600" b="1" i="0">
                 <a:solidFill>
-                  <a:srgbClr val="1D291C"/>
+                  <a:srgbClr val="2C3440"/>
                 </a:solidFill>
                 <a:latin typeface="Arimo"/>
               </a:rPr>
@@ -4826,67 +4826,30 @@
           </a:p>
         </p:txBody>
       </p:sp>
-      <p:sp>
-        <p:nvSpPr>
-          <p:cNvPr id="7" name="Rounded Rectangle 6"/>
-          <p:cNvSpPr/>
+      <p:pic>
+        <p:nvPicPr>
+          <p:cNvPr id="7" name="Picture 6" descr="skin_layers_turnover.png"/>
+          <p:cNvPicPr>
+            <a:picLocks noChangeAspect="1"/>
+          </p:cNvPicPr>
           <p:nvPr/>
-        </p:nvSpPr>
+        </p:nvPicPr>
+        <p:blipFill>
+          <a:blip r:embed="rId2"/>
+          <a:stretch>
+            <a:fillRect/>
+          </a:stretch>
+        </p:blipFill>
         <p:spPr>
           <a:xfrm>
             <a:off x="5179218" y="1339453"/>
             <a:ext cx="3607593" cy="2857500"/>
           </a:xfrm>
-          <a:prstGeom prst="roundRect">
+          <a:prstGeom prst="rect">
             <a:avLst/>
           </a:prstGeom>
-          <a:solidFill>
-            <a:srgbClr val="D7E0CE"/>
-          </a:solidFill>
-          <a:ln w="12700">
-            <a:solidFill>
-              <a:srgbClr val="D7E0CE"/>
-            </a:solidFill>
-          </a:ln>
-        </p:spPr>
-        <p:style>
-          <a:lnRef idx="1">
-            <a:schemeClr val="accent1"/>
-          </a:lnRef>
-          <a:fillRef idx="3">
-            <a:schemeClr val="accent1"/>
-          </a:fillRef>
-          <a:effectRef idx="2">
-            <a:schemeClr val="accent1"/>
-          </a:effectRef>
-          <a:fontRef idx="minor">
-            <a:schemeClr val="lt1"/>
-          </a:fontRef>
-        </p:style>
-        <p:txBody>
-          <a:bodyPr rtlCol="0" anchor="ctr" wrap="square"/>
-          <a:lstStyle/>
-          <a:p>
-            <a:pPr algn="ctr">
-              <a:defRPr sz="1300" b="1">
-                <a:solidFill>
-                  <a:srgbClr val="6D8470"/>
-                </a:solidFill>
-                <a:latin typeface="Arimo"/>
-              </a:defRPr>
-            </a:pPr>
-            <a:r>
-              <a:rPr sz="1300" b="1">
-                <a:solidFill>
-                  <a:srgbClr val="6D8470"/>
-                </a:solidFill>
-                <a:latin typeface="Arimo"/>
-              </a:rPr>
-              <a:t>[Placeholder] Динамика изменения толщины дермы после AHA-терапии</a:t>
-            </a:r>
-          </a:p>
-        </p:txBody>
-      </p:sp>
+        </p:spPr>
+      </p:pic>
     </p:spTree>
   </p:cSld>
   <p:clrMapOvr>
@@ -5031,7 +4994,7 @@
               </a:lnSpc>
               <a:defRPr sz="2600" b="1" i="0">
                 <a:solidFill>
-                  <a:srgbClr val="1D291C"/>
+                  <a:srgbClr val="2C3440"/>
                 </a:solidFill>
                 <a:latin typeface="Arimo"/>
               </a:defRPr>
@@ -5039,7 +5002,7 @@
             <a:r>
               <a:rPr sz="2600" b="1" i="0">
                 <a:solidFill>
-                  <a:srgbClr val="1D291C"/>
+                  <a:srgbClr val="2C3440"/>
                 </a:solidFill>
                 <a:latin typeface="Arimo"/>
               </a:rPr>
@@ -5417,7 +5380,7 @@
               </a:lnSpc>
               <a:defRPr sz="2600" b="1" i="0">
                 <a:solidFill>
-                  <a:srgbClr val="1D291C"/>
+                  <a:srgbClr val="2C3440"/>
                 </a:solidFill>
                 <a:latin typeface="Arimo"/>
               </a:defRPr>
@@ -5425,7 +5388,7 @@
             <a:r>
               <a:rPr sz="2600" b="1" i="0">
                 <a:solidFill>
-                  <a:srgbClr val="1D291C"/>
+                  <a:srgbClr val="2C3440"/>
                 </a:solidFill>
                 <a:latin typeface="Arimo"/>
               </a:rPr>

</xml_diff>

<commit_message>
feat: Add brand chrome layer (logos + Arimo + palette) to all 5 content decks
</commit_message>
<xml_diff>
--- a/06_render/out/deck_exfoliants.pptx
+++ b/06_render/out/deck_exfoliants.pptx
@@ -3147,9 +3147,33 @@
           </a:p>
         </p:txBody>
       </p:sp>
-      <p:sp>
-        <p:nvSpPr>
-          <p:cNvPr id="3" name="TextBox 2"/>
+      <p:pic>
+        <p:nvPicPr>
+          <p:cNvPr id="3" name="Picture 2" descr="descriptor_2C3440.png"/>
+          <p:cNvPicPr>
+            <a:picLocks noChangeAspect="1"/>
+          </p:cNvPicPr>
+          <p:nvPr/>
+        </p:nvPicPr>
+        <p:blipFill>
+          <a:blip r:embed="rId2"/>
+          <a:stretch>
+            <a:fillRect/>
+          </a:stretch>
+        </p:blipFill>
+        <p:spPr>
+          <a:xfrm>
+            <a:off x="357187" y="3661171"/>
+            <a:ext cx="3107531" cy="776882"/>
+          </a:xfrm>
+          <a:prstGeom prst="rect">
+            <a:avLst/>
+          </a:prstGeom>
+        </p:spPr>
+      </p:pic>
+      <p:sp>
+        <p:nvSpPr>
+          <p:cNvPr id="4" name="TextBox 3"/>
           <p:cNvSpPr txBox="1"/>
           <p:nvPr/>
         </p:nvSpPr>
@@ -3194,7 +3218,7 @@
       </p:sp>
       <p:sp>
         <p:nvSpPr>
-          <p:cNvPr id="4" name="TextBox 3"/>
+          <p:cNvPr id="5" name="TextBox 4"/>
           <p:cNvSpPr txBox="1"/>
           <p:nvPr/>
         </p:nvSpPr>
@@ -3239,7 +3263,7 @@
       </p:sp>
       <p:sp>
         <p:nvSpPr>
-          <p:cNvPr id="5" name="TextBox 4"/>
+          <p:cNvPr id="6" name="TextBox 5"/>
           <p:cNvSpPr txBox="1"/>
           <p:nvPr/>
         </p:nvSpPr>
@@ -3284,7 +3308,7 @@
       </p:sp>
       <p:sp>
         <p:nvSpPr>
-          <p:cNvPr id="6" name="Rounded Rectangle 5"/>
+          <p:cNvPr id="7" name="Rounded Rectangle 6"/>
           <p:cNvSpPr/>
           <p:nvPr/>
         </p:nvSpPr>
@@ -3414,9 +3438,33 @@
           </a:p>
         </p:txBody>
       </p:sp>
-      <p:sp>
-        <p:nvSpPr>
-          <p:cNvPr id="3" name="TextBox 2"/>
+      <p:pic>
+        <p:nvPicPr>
+          <p:cNvPr id="3" name="Picture 2" descr="horizontal_2C3440.png"/>
+          <p:cNvPicPr>
+            <a:picLocks noChangeAspect="1"/>
+          </p:cNvPicPr>
+          <p:nvPr/>
+        </p:nvPicPr>
+        <p:blipFill>
+          <a:blip r:embed="rId2"/>
+          <a:stretch>
+            <a:fillRect/>
+          </a:stretch>
+        </p:blipFill>
+        <p:spPr>
+          <a:xfrm>
+            <a:off x="357187" y="982265"/>
+            <a:ext cx="2009179" cy="482203"/>
+          </a:xfrm>
+          <a:prstGeom prst="rect">
+            <a:avLst/>
+          </a:prstGeom>
+        </p:spPr>
+      </p:pic>
+      <p:sp>
+        <p:nvSpPr>
+          <p:cNvPr id="4" name="TextBox 3"/>
           <p:cNvSpPr txBox="1"/>
           <p:nvPr/>
         </p:nvSpPr>
@@ -3461,7 +3509,7 @@
       </p:sp>
       <p:sp>
         <p:nvSpPr>
-          <p:cNvPr id="4" name="TextBox 3"/>
+          <p:cNvPr id="5" name="TextBox 4"/>
           <p:cNvSpPr txBox="1"/>
           <p:nvPr/>
         </p:nvSpPr>
@@ -3506,7 +3554,7 @@
       </p:sp>
       <p:sp>
         <p:nvSpPr>
-          <p:cNvPr id="5" name="TextBox 4"/>
+          <p:cNvPr id="6" name="TextBox 5"/>
           <p:cNvSpPr txBox="1"/>
           <p:nvPr/>
         </p:nvSpPr>
@@ -3583,7 +3631,7 @@
         </p:nvSpPr>
         <p:spPr>
           <a:xfrm>
-            <a:off x="357187" y="4643437"/>
+            <a:off x="357187" y="4464843"/>
             <a:ext cx="4572000" cy="274320"/>
           </a:xfrm>
           <a:prstGeom prst="rect">
@@ -3628,7 +3676,7 @@
         </p:nvSpPr>
         <p:spPr>
           <a:xfrm>
-            <a:off x="5029200" y="4643437"/>
+            <a:off x="5029200" y="4464843"/>
             <a:ext cx="3749039" cy="274320"/>
           </a:xfrm>
           <a:prstGeom prst="rect">
@@ -3667,7 +3715,164 @@
       </p:sp>
       <p:sp>
         <p:nvSpPr>
-          <p:cNvPr id="4" name="TextBox 3"/>
+          <p:cNvPr id="4" name="Rectangle 3"/>
+          <p:cNvSpPr/>
+          <p:nvPr/>
+        </p:nvSpPr>
+        <p:spPr>
+          <a:xfrm>
+            <a:off x="357187" y="4732734"/>
+            <a:ext cx="8429625" cy="8929"/>
+          </a:xfrm>
+          <a:prstGeom prst="rect">
+            <a:avLst/>
+          </a:prstGeom>
+          <a:solidFill>
+            <a:srgbClr val="D7E0CE"/>
+          </a:solidFill>
+          <a:ln>
+            <a:noFill/>
+          </a:ln>
+        </p:spPr>
+        <p:style>
+          <a:lnRef idx="1">
+            <a:schemeClr val="accent1"/>
+          </a:lnRef>
+          <a:fillRef idx="3">
+            <a:schemeClr val="accent1"/>
+          </a:fillRef>
+          <a:effectRef idx="2">
+            <a:schemeClr val="accent1"/>
+          </a:effectRef>
+          <a:fontRef idx="minor">
+            <a:schemeClr val="lt1"/>
+          </a:fontRef>
+        </p:style>
+        <p:txBody>
+          <a:bodyPr rtlCol="0" anchor="ctr"/>
+          <a:lstStyle/>
+          <a:p>
+            <a:pPr algn="ctr"/>
+          </a:p>
+        </p:txBody>
+      </p:sp>
+      <p:pic>
+        <p:nvPicPr>
+          <p:cNvPr id="5" name="Picture 4" descr="mark_6D8470.png"/>
+          <p:cNvPicPr>
+            <a:picLocks noChangeAspect="1"/>
+          </p:cNvPicPr>
+          <p:nvPr/>
+        </p:nvPicPr>
+        <p:blipFill>
+          <a:blip r:embed="rId2"/>
+          <a:stretch>
+            <a:fillRect/>
+          </a:stretch>
+        </p:blipFill>
+        <p:spPr>
+          <a:xfrm>
+            <a:off x="357187" y="4848820"/>
+            <a:ext cx="178593" cy="178593"/>
+          </a:xfrm>
+          <a:prstGeom prst="rect">
+            <a:avLst/>
+          </a:prstGeom>
+        </p:spPr>
+      </p:pic>
+      <p:sp>
+        <p:nvSpPr>
+          <p:cNvPr id="6" name="TextBox 5"/>
+          <p:cNvSpPr txBox="1"/>
+          <p:nvPr/>
+        </p:nvSpPr>
+        <p:spPr>
+          <a:xfrm>
+            <a:off x="607218" y="4830960"/>
+            <a:ext cx="1785937" cy="178593"/>
+          </a:xfrm>
+          <a:prstGeom prst="rect">
+            <a:avLst/>
+          </a:prstGeom>
+          <a:noFill/>
+        </p:spPr>
+        <p:txBody>
+          <a:bodyPr wrap="square" tIns="0" bIns="0" lIns="0" rIns="0">
+            <a:spAutoFit/>
+          </a:bodyPr>
+          <a:lstStyle/>
+          <a:p>
+            <a:pPr algn="l">
+              <a:lnSpc>
+                <a:spcPct val="120000"/>
+              </a:lnSpc>
+              <a:defRPr sz="1100" b="1" i="0">
+                <a:solidFill>
+                  <a:srgbClr val="3D4A40"/>
+                </a:solidFill>
+                <a:latin typeface="Arimo"/>
+              </a:defRPr>
+            </a:pPr>
+            <a:r>
+              <a:rPr sz="1100" b="1" i="0">
+                <a:solidFill>
+                  <a:srgbClr val="3D4A40"/>
+                </a:solidFill>
+                <a:latin typeface="Arimo"/>
+              </a:rPr>
+              <a:t>YM PROSKIN</a:t>
+            </a:r>
+          </a:p>
+        </p:txBody>
+      </p:sp>
+      <p:sp>
+        <p:nvSpPr>
+          <p:cNvPr id="7" name="TextBox 6"/>
+          <p:cNvSpPr txBox="1"/>
+          <p:nvPr/>
+        </p:nvSpPr>
+        <p:spPr>
+          <a:xfrm>
+            <a:off x="8251031" y="4830960"/>
+            <a:ext cx="535781" cy="178593"/>
+          </a:xfrm>
+          <a:prstGeom prst="rect">
+            <a:avLst/>
+          </a:prstGeom>
+          <a:noFill/>
+        </p:spPr>
+        <p:txBody>
+          <a:bodyPr wrap="square" tIns="0" bIns="0" lIns="0" rIns="0">
+            <a:spAutoFit/>
+          </a:bodyPr>
+          <a:lstStyle/>
+          <a:p>
+            <a:pPr algn="r">
+              <a:lnSpc>
+                <a:spcPct val="120000"/>
+              </a:lnSpc>
+              <a:defRPr sz="1100" b="0" i="0">
+                <a:solidFill>
+                  <a:srgbClr val="6D8470"/>
+                </a:solidFill>
+                <a:latin typeface="Arimo"/>
+              </a:defRPr>
+            </a:pPr>
+            <a:r>
+              <a:rPr sz="1100" b="0" i="0">
+                <a:solidFill>
+                  <a:srgbClr val="6D8470"/>
+                </a:solidFill>
+                <a:latin typeface="Arimo"/>
+              </a:rPr>
+              <a:t>3</a:t>
+            </a:r>
+          </a:p>
+        </p:txBody>
+      </p:sp>
+      <p:sp>
+        <p:nvSpPr>
+          <p:cNvPr id="8" name="TextBox 7"/>
           <p:cNvSpPr txBox="1"/>
           <p:nvPr/>
         </p:nvSpPr>
@@ -3712,7 +3917,7 @@
       </p:sp>
       <p:sp>
         <p:nvSpPr>
-          <p:cNvPr id="5" name="TextBox 4"/>
+          <p:cNvPr id="9" name="TextBox 8"/>
           <p:cNvSpPr txBox="1"/>
           <p:nvPr/>
         </p:nvSpPr>
@@ -3757,7 +3962,7 @@
       </p:sp>
       <p:sp>
         <p:nvSpPr>
-          <p:cNvPr id="6" name="TextBox 5"/>
+          <p:cNvPr id="10" name="TextBox 9"/>
           <p:cNvSpPr txBox="1"/>
           <p:nvPr/>
         </p:nvSpPr>
@@ -3872,14 +4077,14 @@
       </p:sp>
       <p:pic>
         <p:nvPicPr>
-          <p:cNvPr id="7" name="Picture 6" descr="desmosome_desmolysis.png"/>
+          <p:cNvPr id="11" name="Picture 10" descr="desmosome_desmolysis.png"/>
           <p:cNvPicPr>
             <a:picLocks noChangeAspect="1"/>
           </p:cNvPicPr>
           <p:nvPr/>
         </p:nvPicPr>
         <p:blipFill>
-          <a:blip r:embed="rId2"/>
+          <a:blip r:embed="rId3"/>
           <a:stretch>
             <a:fillRect/>
           </a:stretch>
@@ -3928,7 +4133,7 @@
         </p:nvSpPr>
         <p:spPr>
           <a:xfrm>
-            <a:off x="357187" y="4643437"/>
+            <a:off x="357187" y="4464843"/>
             <a:ext cx="4572000" cy="274320"/>
           </a:xfrm>
           <a:prstGeom prst="rect">
@@ -3973,7 +4178,7 @@
         </p:nvSpPr>
         <p:spPr>
           <a:xfrm>
-            <a:off x="5029200" y="4643437"/>
+            <a:off x="5029200" y="4464843"/>
             <a:ext cx="3749039" cy="274320"/>
           </a:xfrm>
           <a:prstGeom prst="rect">
@@ -4012,115 +4217,23 @@
       </p:sp>
       <p:sp>
         <p:nvSpPr>
-          <p:cNvPr id="4" name="TextBox 3"/>
-          <p:cNvSpPr txBox="1"/>
-          <p:nvPr/>
-        </p:nvSpPr>
-        <p:spPr>
-          <a:xfrm>
-            <a:off x="357187" y="357187"/>
-            <a:ext cx="8429625" cy="401835"/>
-          </a:xfrm>
-          <a:prstGeom prst="rect">
-            <a:avLst/>
-          </a:prstGeom>
-          <a:noFill/>
-        </p:spPr>
-        <p:txBody>
-          <a:bodyPr wrap="square" tIns="0" bIns="0" lIns="0" rIns="0">
-            <a:spAutoFit/>
-          </a:bodyPr>
-          <a:lstStyle/>
-          <a:p>
-            <a:pPr algn="l">
-              <a:lnSpc>
-                <a:spcPct val="120000"/>
-              </a:lnSpc>
-              <a:defRPr sz="2600" b="1" i="0">
-                <a:solidFill>
-                  <a:srgbClr val="2C3440"/>
-                </a:solidFill>
-                <a:latin typeface="Arimo"/>
-              </a:defRPr>
-            </a:pPr>
-            <a:r>
-              <a:rPr sz="2600" b="1" i="0">
-                <a:solidFill>
-                  <a:srgbClr val="2C3440"/>
-                </a:solidFill>
-                <a:latin typeface="Arimo"/>
-              </a:rPr>
-              <a:t>Терапия Акне и Постакне</a:t>
-            </a:r>
-          </a:p>
-        </p:txBody>
-      </p:sp>
-      <p:sp>
-        <p:nvSpPr>
-          <p:cNvPr id="5" name="TextBox 4"/>
-          <p:cNvSpPr txBox="1"/>
-          <p:nvPr/>
-        </p:nvSpPr>
-        <p:spPr>
-          <a:xfrm>
-            <a:off x="357187" y="803671"/>
-            <a:ext cx="8429625" cy="267890"/>
-          </a:xfrm>
-          <a:prstGeom prst="rect">
-            <a:avLst/>
-          </a:prstGeom>
-          <a:noFill/>
-        </p:spPr>
-        <p:txBody>
-          <a:bodyPr wrap="square" tIns="0" bIns="0" lIns="0" rIns="0">
-            <a:spAutoFit/>
-          </a:bodyPr>
-          <a:lstStyle/>
-          <a:p>
-            <a:pPr algn="l">
-              <a:lnSpc>
-                <a:spcPct val="120000"/>
-              </a:lnSpc>
-              <a:defRPr sz="1500" b="0" i="0">
-                <a:solidFill>
-                  <a:srgbClr val="6D8470"/>
-                </a:solidFill>
-                <a:latin typeface="Arimo"/>
-              </a:defRPr>
-            </a:pPr>
-            <a:r>
-              <a:rPr sz="1500" b="0" i="0">
-                <a:solidFill>
-                  <a:srgbClr val="6D8470"/>
-                </a:solidFill>
-                <a:latin typeface="Arimo"/>
-              </a:rPr>
-              <a:t>Применение моно- и комбинированных пилингов в лечении акне</a:t>
-            </a:r>
-          </a:p>
-        </p:txBody>
-      </p:sp>
-      <p:sp>
-        <p:nvSpPr>
-          <p:cNvPr id="6" name="Rounded Rectangle 5"/>
+          <p:cNvPr id="4" name="Rectangle 3"/>
           <p:cNvSpPr/>
           <p:nvPr/>
         </p:nvSpPr>
         <p:spPr>
           <a:xfrm>
-            <a:off x="357187" y="1339453"/>
-            <a:ext cx="2624328" cy="2834640"/>
-          </a:xfrm>
-          <a:prstGeom prst="roundRect">
+            <a:off x="357187" y="4732734"/>
+            <a:ext cx="8429625" cy="8929"/>
+          </a:xfrm>
+          <a:prstGeom prst="rect">
             <a:avLst/>
           </a:prstGeom>
           <a:solidFill>
-            <a:srgbClr val="E6D2CA"/>
+            <a:srgbClr val="D7E0CE"/>
           </a:solidFill>
-          <a:ln w="12700">
-            <a:solidFill>
-              <a:srgbClr val="D7E0CE"/>
-            </a:solidFill>
+          <a:ln>
+            <a:noFill/>
           </a:ln>
         </p:spPr>
         <p:style>
@@ -4145,16 +4258,40 @@
           </a:p>
         </p:txBody>
       </p:sp>
-      <p:sp>
-        <p:nvSpPr>
-          <p:cNvPr id="7" name="TextBox 6"/>
+      <p:pic>
+        <p:nvPicPr>
+          <p:cNvPr id="5" name="Picture 4" descr="mark_6D8470.png"/>
+          <p:cNvPicPr>
+            <a:picLocks noChangeAspect="1"/>
+          </p:cNvPicPr>
+          <p:nvPr/>
+        </p:nvPicPr>
+        <p:blipFill>
+          <a:blip r:embed="rId2"/>
+          <a:stretch>
+            <a:fillRect/>
+          </a:stretch>
+        </p:blipFill>
+        <p:spPr>
+          <a:xfrm>
+            <a:off x="357187" y="4848820"/>
+            <a:ext cx="178593" cy="178593"/>
+          </a:xfrm>
+          <a:prstGeom prst="rect">
+            <a:avLst/>
+          </a:prstGeom>
+        </p:spPr>
+      </p:pic>
+      <p:sp>
+        <p:nvSpPr>
+          <p:cNvPr id="6" name="TextBox 5"/>
           <p:cNvSpPr txBox="1"/>
           <p:nvPr/>
         </p:nvSpPr>
         <p:spPr>
           <a:xfrm>
-            <a:off x="540067" y="1518046"/>
-            <a:ext cx="2258568" cy="457200"/>
+            <a:off x="607218" y="4830960"/>
+            <a:ext cx="1785937" cy="178593"/>
           </a:xfrm>
           <a:prstGeom prst="rect">
             <a:avLst/>
@@ -4171,21 +4308,66 @@
               <a:lnSpc>
                 <a:spcPct val="120000"/>
               </a:lnSpc>
-              <a:defRPr sz="1800" b="1" i="0">
-                <a:solidFill>
-                  <a:srgbClr val="2C3440"/>
+              <a:defRPr sz="1100" b="1" i="0">
+                <a:solidFill>
+                  <a:srgbClr val="3D4A40"/>
                 </a:solidFill>
                 <a:latin typeface="Arimo"/>
               </a:defRPr>
             </a:pPr>
             <a:r>
-              <a:rPr sz="1800" b="1" i="0">
-                <a:solidFill>
-                  <a:srgbClr val="2C3440"/>
+              <a:rPr sz="1100" b="1" i="0">
+                <a:solidFill>
+                  <a:srgbClr val="3D4A40"/>
                 </a:solidFill>
                 <a:latin typeface="Arimo"/>
               </a:rPr>
-              <a:t>Комбинация AHA + BHA</a:t>
+              <a:t>YM PROSKIN</a:t>
+            </a:r>
+          </a:p>
+        </p:txBody>
+      </p:sp>
+      <p:sp>
+        <p:nvSpPr>
+          <p:cNvPr id="7" name="TextBox 6"/>
+          <p:cNvSpPr txBox="1"/>
+          <p:nvPr/>
+        </p:nvSpPr>
+        <p:spPr>
+          <a:xfrm>
+            <a:off x="8251031" y="4830960"/>
+            <a:ext cx="535781" cy="178593"/>
+          </a:xfrm>
+          <a:prstGeom prst="rect">
+            <a:avLst/>
+          </a:prstGeom>
+          <a:noFill/>
+        </p:spPr>
+        <p:txBody>
+          <a:bodyPr wrap="square" tIns="0" bIns="0" lIns="0" rIns="0">
+            <a:spAutoFit/>
+          </a:bodyPr>
+          <a:lstStyle/>
+          <a:p>
+            <a:pPr algn="r">
+              <a:lnSpc>
+                <a:spcPct val="120000"/>
+              </a:lnSpc>
+              <a:defRPr sz="1100" b="0" i="0">
+                <a:solidFill>
+                  <a:srgbClr val="6D8470"/>
+                </a:solidFill>
+                <a:latin typeface="Arimo"/>
+              </a:defRPr>
+            </a:pPr>
+            <a:r>
+              <a:rPr sz="1100" b="0" i="0">
+                <a:solidFill>
+                  <a:srgbClr val="6D8470"/>
+                </a:solidFill>
+                <a:latin typeface="Arimo"/>
+              </a:rPr>
+              <a:t>4</a:t>
             </a:r>
           </a:p>
         </p:txBody>
@@ -4198,8 +4380,8 @@
         </p:nvSpPr>
         <p:spPr>
           <a:xfrm>
-            <a:off x="540067" y="2053828"/>
-            <a:ext cx="2258568" cy="1920240"/>
+            <a:off x="357187" y="357187"/>
+            <a:ext cx="8429625" cy="401835"/>
           </a:xfrm>
           <a:prstGeom prst="rect">
             <a:avLst/>
@@ -4216,34 +4398,79 @@
               <a:lnSpc>
                 <a:spcPct val="120000"/>
               </a:lnSpc>
-              <a:defRPr sz="1300" b="0" i="0">
-                <a:solidFill>
-                  <a:srgbClr val="3D4A40"/>
+              <a:defRPr sz="2600" b="1" i="0">
+                <a:solidFill>
+                  <a:srgbClr val="2C3440"/>
                 </a:solidFill>
                 <a:latin typeface="Arimo"/>
               </a:defRPr>
             </a:pPr>
             <a:r>
-              <a:rPr sz="1300" b="0" i="0">
-                <a:solidFill>
-                  <a:srgbClr val="3D4A40"/>
+              <a:rPr sz="2600" b="1" i="0">
+                <a:solidFill>
+                  <a:srgbClr val="2C3440"/>
                 </a:solidFill>
                 <a:latin typeface="Arimo"/>
               </a:rPr>
-              <a:t>Совместное использование гликолевой и салициловой кислот улучшает состояние кожи при легком и среднем акне.</a:t>
-            </a:r>
-          </a:p>
-        </p:txBody>
-      </p:sp>
-      <p:sp>
-        <p:nvSpPr>
-          <p:cNvPr id="9" name="Rounded Rectangle 8"/>
+              <a:t>Терапия Акне и Постакне</a:t>
+            </a:r>
+          </a:p>
+        </p:txBody>
+      </p:sp>
+      <p:sp>
+        <p:nvSpPr>
+          <p:cNvPr id="9" name="TextBox 8"/>
+          <p:cNvSpPr txBox="1"/>
+          <p:nvPr/>
+        </p:nvSpPr>
+        <p:spPr>
+          <a:xfrm>
+            <a:off x="357187" y="803671"/>
+            <a:ext cx="8429625" cy="267890"/>
+          </a:xfrm>
+          <a:prstGeom prst="rect">
+            <a:avLst/>
+          </a:prstGeom>
+          <a:noFill/>
+        </p:spPr>
+        <p:txBody>
+          <a:bodyPr wrap="square" tIns="0" bIns="0" lIns="0" rIns="0">
+            <a:spAutoFit/>
+          </a:bodyPr>
+          <a:lstStyle/>
+          <a:p>
+            <a:pPr algn="l">
+              <a:lnSpc>
+                <a:spcPct val="120000"/>
+              </a:lnSpc>
+              <a:defRPr sz="1500" b="0" i="0">
+                <a:solidFill>
+                  <a:srgbClr val="6D8470"/>
+                </a:solidFill>
+                <a:latin typeface="Arimo"/>
+              </a:defRPr>
+            </a:pPr>
+            <a:r>
+              <a:rPr sz="1500" b="0" i="0">
+                <a:solidFill>
+                  <a:srgbClr val="6D8470"/>
+                </a:solidFill>
+                <a:latin typeface="Arimo"/>
+              </a:rPr>
+              <a:t>Применение моно- и комбинированных пилингов в лечении акне</a:t>
+            </a:r>
+          </a:p>
+        </p:txBody>
+      </p:sp>
+      <p:sp>
+        <p:nvSpPr>
+          <p:cNvPr id="10" name="Rounded Rectangle 9"/>
           <p:cNvSpPr/>
           <p:nvPr/>
         </p:nvSpPr>
         <p:spPr>
           <a:xfrm>
-            <a:off x="3259335" y="1339453"/>
+            <a:off x="357187" y="1339453"/>
             <a:ext cx="2624328" cy="2834640"/>
           </a:xfrm>
           <a:prstGeom prst="roundRect">
@@ -4282,13 +4509,13 @@
       </p:sp>
       <p:sp>
         <p:nvSpPr>
-          <p:cNvPr id="10" name="TextBox 9"/>
+          <p:cNvPr id="11" name="TextBox 10"/>
           <p:cNvSpPr txBox="1"/>
           <p:nvPr/>
         </p:nvSpPr>
         <p:spPr>
           <a:xfrm>
-            <a:off x="3442215" y="1518046"/>
+            <a:off x="540067" y="1518046"/>
             <a:ext cx="2258568" cy="457200"/>
           </a:xfrm>
           <a:prstGeom prst="rect">
@@ -4320,20 +4547,20 @@
                 </a:solidFill>
                 <a:latin typeface="Arimo"/>
               </a:rPr>
-              <a:t>Салицилово-миндальный пилинг</a:t>
-            </a:r>
-          </a:p>
-        </p:txBody>
-      </p:sp>
-      <p:sp>
-        <p:nvSpPr>
-          <p:cNvPr id="11" name="TextBox 10"/>
+              <a:t>Комбинация AHA + BHA</a:t>
+            </a:r>
+          </a:p>
+        </p:txBody>
+      </p:sp>
+      <p:sp>
+        <p:nvSpPr>
+          <p:cNvPr id="12" name="TextBox 11"/>
           <p:cNvSpPr txBox="1"/>
           <p:nvPr/>
         </p:nvSpPr>
         <p:spPr>
           <a:xfrm>
-            <a:off x="3442215" y="2053828"/>
+            <a:off x="540067" y="2053828"/>
             <a:ext cx="2258568" cy="1920240"/>
           </a:xfrm>
           <a:prstGeom prst="rect">
@@ -4365,20 +4592,20 @@
                 </a:solidFill>
                 <a:latin typeface="Arimo"/>
               </a:rPr>
-              <a:t>Комбинация кислот (включая 20% салициловой и 10% миндальной) эффективна против воспалений и постакне.</a:t>
-            </a:r>
-          </a:p>
-        </p:txBody>
-      </p:sp>
-      <p:sp>
-        <p:nvSpPr>
-          <p:cNvPr id="12" name="Rounded Rectangle 11"/>
+              <a:t>Совместное использование гликолевой и салициловой кислот улучшает состояние кожи при легком и среднем акне.</a:t>
+            </a:r>
+          </a:p>
+        </p:txBody>
+      </p:sp>
+      <p:sp>
+        <p:nvSpPr>
+          <p:cNvPr id="13" name="Rounded Rectangle 12"/>
           <p:cNvSpPr/>
           <p:nvPr/>
         </p:nvSpPr>
         <p:spPr>
           <a:xfrm>
-            <a:off x="6161484" y="1339453"/>
+            <a:off x="3259335" y="1339453"/>
             <a:ext cx="2624328" cy="2834640"/>
           </a:xfrm>
           <a:prstGeom prst="roundRect">
@@ -4417,13 +4644,13 @@
       </p:sp>
       <p:sp>
         <p:nvSpPr>
-          <p:cNvPr id="13" name="TextBox 12"/>
+          <p:cNvPr id="14" name="TextBox 13"/>
           <p:cNvSpPr txBox="1"/>
           <p:nvPr/>
         </p:nvSpPr>
         <p:spPr>
           <a:xfrm>
-            <a:off x="6344364" y="1518046"/>
+            <a:off x="3442215" y="1518046"/>
             <a:ext cx="2258568" cy="457200"/>
           </a:xfrm>
           <a:prstGeom prst="rect">
@@ -4455,6 +4682,141 @@
                 </a:solidFill>
                 <a:latin typeface="Arimo"/>
               </a:rPr>
+              <a:t>Салицилово-миндальный пилинг</a:t>
+            </a:r>
+          </a:p>
+        </p:txBody>
+      </p:sp>
+      <p:sp>
+        <p:nvSpPr>
+          <p:cNvPr id="15" name="TextBox 14"/>
+          <p:cNvSpPr txBox="1"/>
+          <p:nvPr/>
+        </p:nvSpPr>
+        <p:spPr>
+          <a:xfrm>
+            <a:off x="3442215" y="2053828"/>
+            <a:ext cx="2258568" cy="1920240"/>
+          </a:xfrm>
+          <a:prstGeom prst="rect">
+            <a:avLst/>
+          </a:prstGeom>
+          <a:noFill/>
+        </p:spPr>
+        <p:txBody>
+          <a:bodyPr wrap="square" tIns="0" bIns="0" lIns="0" rIns="0">
+            <a:spAutoFit/>
+          </a:bodyPr>
+          <a:lstStyle/>
+          <a:p>
+            <a:pPr algn="l">
+              <a:lnSpc>
+                <a:spcPct val="120000"/>
+              </a:lnSpc>
+              <a:defRPr sz="1300" b="0" i="0">
+                <a:solidFill>
+                  <a:srgbClr val="3D4A40"/>
+                </a:solidFill>
+                <a:latin typeface="Arimo"/>
+              </a:defRPr>
+            </a:pPr>
+            <a:r>
+              <a:rPr sz="1300" b="0" i="0">
+                <a:solidFill>
+                  <a:srgbClr val="3D4A40"/>
+                </a:solidFill>
+                <a:latin typeface="Arimo"/>
+              </a:rPr>
+              <a:t>Комбинация кислот (включая 20% салициловой и 10% миндальной) эффективна против воспалений и постакне.</a:t>
+            </a:r>
+          </a:p>
+        </p:txBody>
+      </p:sp>
+      <p:sp>
+        <p:nvSpPr>
+          <p:cNvPr id="16" name="Rounded Rectangle 15"/>
+          <p:cNvSpPr/>
+          <p:nvPr/>
+        </p:nvSpPr>
+        <p:spPr>
+          <a:xfrm>
+            <a:off x="6161484" y="1339453"/>
+            <a:ext cx="2624328" cy="2834640"/>
+          </a:xfrm>
+          <a:prstGeom prst="roundRect">
+            <a:avLst/>
+          </a:prstGeom>
+          <a:solidFill>
+            <a:srgbClr val="E6D2CA"/>
+          </a:solidFill>
+          <a:ln w="12700">
+            <a:solidFill>
+              <a:srgbClr val="D7E0CE"/>
+            </a:solidFill>
+          </a:ln>
+        </p:spPr>
+        <p:style>
+          <a:lnRef idx="1">
+            <a:schemeClr val="accent1"/>
+          </a:lnRef>
+          <a:fillRef idx="3">
+            <a:schemeClr val="accent1"/>
+          </a:fillRef>
+          <a:effectRef idx="2">
+            <a:schemeClr val="accent1"/>
+          </a:effectRef>
+          <a:fontRef idx="minor">
+            <a:schemeClr val="lt1"/>
+          </a:fontRef>
+        </p:style>
+        <p:txBody>
+          <a:bodyPr rtlCol="0" anchor="ctr"/>
+          <a:lstStyle/>
+          <a:p>
+            <a:pPr algn="ctr"/>
+          </a:p>
+        </p:txBody>
+      </p:sp>
+      <p:sp>
+        <p:nvSpPr>
+          <p:cNvPr id="17" name="TextBox 16"/>
+          <p:cNvSpPr txBox="1"/>
+          <p:nvPr/>
+        </p:nvSpPr>
+        <p:spPr>
+          <a:xfrm>
+            <a:off x="6344364" y="1518046"/>
+            <a:ext cx="2258568" cy="457200"/>
+          </a:xfrm>
+          <a:prstGeom prst="rect">
+            <a:avLst/>
+          </a:prstGeom>
+          <a:noFill/>
+        </p:spPr>
+        <p:txBody>
+          <a:bodyPr wrap="square" tIns="0" bIns="0" lIns="0" rIns="0">
+            <a:spAutoFit/>
+          </a:bodyPr>
+          <a:lstStyle/>
+          <a:p>
+            <a:pPr algn="l">
+              <a:lnSpc>
+                <a:spcPct val="120000"/>
+              </a:lnSpc>
+              <a:defRPr sz="1800" b="1" i="0">
+                <a:solidFill>
+                  <a:srgbClr val="2C3440"/>
+                </a:solidFill>
+                <a:latin typeface="Arimo"/>
+              </a:defRPr>
+            </a:pPr>
+            <a:r>
+              <a:rPr sz="1800" b="1" i="0">
+                <a:solidFill>
+                  <a:srgbClr val="2C3440"/>
+                </a:solidFill>
+                <a:latin typeface="Arimo"/>
+              </a:rPr>
               <a:t>Миндальный пилинг 45%</a:t>
             </a:r>
           </a:p>
@@ -4462,7 +4824,7 @@
       </p:sp>
       <p:sp>
         <p:nvSpPr>
-          <p:cNvPr id="14" name="TextBox 13"/>
+          <p:cNvPr id="18" name="TextBox 17"/>
           <p:cNvSpPr txBox="1"/>
           <p:nvPr/>
         </p:nvSpPr>
@@ -4539,7 +4901,7 @@
         </p:nvSpPr>
         <p:spPr>
           <a:xfrm>
-            <a:off x="357187" y="4643437"/>
+            <a:off x="357187" y="4464843"/>
             <a:ext cx="4572000" cy="274320"/>
           </a:xfrm>
           <a:prstGeom prst="rect">
@@ -4584,7 +4946,7 @@
         </p:nvSpPr>
         <p:spPr>
           <a:xfrm>
-            <a:off x="5029200" y="4643437"/>
+            <a:off x="5029200" y="4464843"/>
             <a:ext cx="3749039" cy="274320"/>
           </a:xfrm>
           <a:prstGeom prst="rect">
@@ -4623,7 +4985,164 @@
       </p:sp>
       <p:sp>
         <p:nvSpPr>
-          <p:cNvPr id="4" name="TextBox 3"/>
+          <p:cNvPr id="4" name="Rectangle 3"/>
+          <p:cNvSpPr/>
+          <p:nvPr/>
+        </p:nvSpPr>
+        <p:spPr>
+          <a:xfrm>
+            <a:off x="357187" y="4732734"/>
+            <a:ext cx="8429625" cy="8929"/>
+          </a:xfrm>
+          <a:prstGeom prst="rect">
+            <a:avLst/>
+          </a:prstGeom>
+          <a:solidFill>
+            <a:srgbClr val="D7E0CE"/>
+          </a:solidFill>
+          <a:ln>
+            <a:noFill/>
+          </a:ln>
+        </p:spPr>
+        <p:style>
+          <a:lnRef idx="1">
+            <a:schemeClr val="accent1"/>
+          </a:lnRef>
+          <a:fillRef idx="3">
+            <a:schemeClr val="accent1"/>
+          </a:fillRef>
+          <a:effectRef idx="2">
+            <a:schemeClr val="accent1"/>
+          </a:effectRef>
+          <a:fontRef idx="minor">
+            <a:schemeClr val="lt1"/>
+          </a:fontRef>
+        </p:style>
+        <p:txBody>
+          <a:bodyPr rtlCol="0" anchor="ctr"/>
+          <a:lstStyle/>
+          <a:p>
+            <a:pPr algn="ctr"/>
+          </a:p>
+        </p:txBody>
+      </p:sp>
+      <p:pic>
+        <p:nvPicPr>
+          <p:cNvPr id="5" name="Picture 4" descr="mark_6D8470.png"/>
+          <p:cNvPicPr>
+            <a:picLocks noChangeAspect="1"/>
+          </p:cNvPicPr>
+          <p:nvPr/>
+        </p:nvPicPr>
+        <p:blipFill>
+          <a:blip r:embed="rId2"/>
+          <a:stretch>
+            <a:fillRect/>
+          </a:stretch>
+        </p:blipFill>
+        <p:spPr>
+          <a:xfrm>
+            <a:off x="357187" y="4848820"/>
+            <a:ext cx="178593" cy="178593"/>
+          </a:xfrm>
+          <a:prstGeom prst="rect">
+            <a:avLst/>
+          </a:prstGeom>
+        </p:spPr>
+      </p:pic>
+      <p:sp>
+        <p:nvSpPr>
+          <p:cNvPr id="6" name="TextBox 5"/>
+          <p:cNvSpPr txBox="1"/>
+          <p:nvPr/>
+        </p:nvSpPr>
+        <p:spPr>
+          <a:xfrm>
+            <a:off x="607218" y="4830960"/>
+            <a:ext cx="1785937" cy="178593"/>
+          </a:xfrm>
+          <a:prstGeom prst="rect">
+            <a:avLst/>
+          </a:prstGeom>
+          <a:noFill/>
+        </p:spPr>
+        <p:txBody>
+          <a:bodyPr wrap="square" tIns="0" bIns="0" lIns="0" rIns="0">
+            <a:spAutoFit/>
+          </a:bodyPr>
+          <a:lstStyle/>
+          <a:p>
+            <a:pPr algn="l">
+              <a:lnSpc>
+                <a:spcPct val="120000"/>
+              </a:lnSpc>
+              <a:defRPr sz="1100" b="1" i="0">
+                <a:solidFill>
+                  <a:srgbClr val="3D4A40"/>
+                </a:solidFill>
+                <a:latin typeface="Arimo"/>
+              </a:defRPr>
+            </a:pPr>
+            <a:r>
+              <a:rPr sz="1100" b="1" i="0">
+                <a:solidFill>
+                  <a:srgbClr val="3D4A40"/>
+                </a:solidFill>
+                <a:latin typeface="Arimo"/>
+              </a:rPr>
+              <a:t>YM PROSKIN</a:t>
+            </a:r>
+          </a:p>
+        </p:txBody>
+      </p:sp>
+      <p:sp>
+        <p:nvSpPr>
+          <p:cNvPr id="7" name="TextBox 6"/>
+          <p:cNvSpPr txBox="1"/>
+          <p:nvPr/>
+        </p:nvSpPr>
+        <p:spPr>
+          <a:xfrm>
+            <a:off x="8251031" y="4830960"/>
+            <a:ext cx="535781" cy="178593"/>
+          </a:xfrm>
+          <a:prstGeom prst="rect">
+            <a:avLst/>
+          </a:prstGeom>
+          <a:noFill/>
+        </p:spPr>
+        <p:txBody>
+          <a:bodyPr wrap="square" tIns="0" bIns="0" lIns="0" rIns="0">
+            <a:spAutoFit/>
+          </a:bodyPr>
+          <a:lstStyle/>
+          <a:p>
+            <a:pPr algn="r">
+              <a:lnSpc>
+                <a:spcPct val="120000"/>
+              </a:lnSpc>
+              <a:defRPr sz="1100" b="0" i="0">
+                <a:solidFill>
+                  <a:srgbClr val="6D8470"/>
+                </a:solidFill>
+                <a:latin typeface="Arimo"/>
+              </a:defRPr>
+            </a:pPr>
+            <a:r>
+              <a:rPr sz="1100" b="0" i="0">
+                <a:solidFill>
+                  <a:srgbClr val="6D8470"/>
+                </a:solidFill>
+                <a:latin typeface="Arimo"/>
+              </a:rPr>
+              <a:t>5</a:t>
+            </a:r>
+          </a:p>
+        </p:txBody>
+      </p:sp>
+      <p:sp>
+        <p:nvSpPr>
+          <p:cNvPr id="8" name="TextBox 7"/>
           <p:cNvSpPr txBox="1"/>
           <p:nvPr/>
         </p:nvSpPr>
@@ -4668,7 +5187,7 @@
       </p:sp>
       <p:sp>
         <p:nvSpPr>
-          <p:cNvPr id="5" name="TextBox 4"/>
+          <p:cNvPr id="9" name="TextBox 8"/>
           <p:cNvSpPr txBox="1"/>
           <p:nvPr/>
         </p:nvSpPr>
@@ -4713,7 +5232,7 @@
       </p:sp>
       <p:sp>
         <p:nvSpPr>
-          <p:cNvPr id="6" name="TextBox 5"/>
+          <p:cNvPr id="10" name="TextBox 9"/>
           <p:cNvSpPr txBox="1"/>
           <p:nvPr/>
         </p:nvSpPr>
@@ -4828,14 +5347,14 @@
       </p:sp>
       <p:pic>
         <p:nvPicPr>
-          <p:cNvPr id="7" name="Picture 6" descr="skin_layers_turnover.png"/>
+          <p:cNvPr id="11" name="Picture 10" descr="skin_layers_turnover.png"/>
           <p:cNvPicPr>
             <a:picLocks noChangeAspect="1"/>
           </p:cNvPicPr>
           <p:nvPr/>
         </p:nvPicPr>
         <p:blipFill>
-          <a:blip r:embed="rId2"/>
+          <a:blip r:embed="rId3"/>
           <a:stretch>
             <a:fillRect/>
           </a:stretch>
@@ -4884,7 +5403,7 @@
         </p:nvSpPr>
         <p:spPr>
           <a:xfrm>
-            <a:off x="357187" y="4643437"/>
+            <a:off x="357187" y="4464843"/>
             <a:ext cx="4572000" cy="274320"/>
           </a:xfrm>
           <a:prstGeom prst="rect">
@@ -4929,7 +5448,7 @@
         </p:nvSpPr>
         <p:spPr>
           <a:xfrm>
-            <a:off x="5029200" y="4643437"/>
+            <a:off x="5029200" y="4464843"/>
             <a:ext cx="3749039" cy="274320"/>
           </a:xfrm>
           <a:prstGeom prst="rect">
@@ -4968,115 +5487,23 @@
       </p:sp>
       <p:sp>
         <p:nvSpPr>
-          <p:cNvPr id="4" name="TextBox 3"/>
-          <p:cNvSpPr txBox="1"/>
-          <p:nvPr/>
-        </p:nvSpPr>
-        <p:spPr>
-          <a:xfrm>
-            <a:off x="357187" y="357187"/>
-            <a:ext cx="8429625" cy="401835"/>
-          </a:xfrm>
-          <a:prstGeom prst="rect">
-            <a:avLst/>
-          </a:prstGeom>
-          <a:noFill/>
-        </p:spPr>
-        <p:txBody>
-          <a:bodyPr wrap="square" tIns="0" bIns="0" lIns="0" rIns="0">
-            <a:spAutoFit/>
-          </a:bodyPr>
-          <a:lstStyle/>
-          <a:p>
-            <a:pPr algn="l">
-              <a:lnSpc>
-                <a:spcPct val="120000"/>
-              </a:lnSpc>
-              <a:defRPr sz="2600" b="1" i="0">
-                <a:solidFill>
-                  <a:srgbClr val="2C3440"/>
-                </a:solidFill>
-                <a:latin typeface="Arimo"/>
-              </a:defRPr>
-            </a:pPr>
-            <a:r>
-              <a:rPr sz="2600" b="1" i="0">
-                <a:solidFill>
-                  <a:srgbClr val="2C3440"/>
-                </a:solidFill>
-                <a:latin typeface="Arimo"/>
-              </a:rPr>
-              <a:t>Меры Предосторожности</a:t>
-            </a:r>
-          </a:p>
-        </p:txBody>
-      </p:sp>
-      <p:sp>
-        <p:nvSpPr>
-          <p:cNvPr id="5" name="TextBox 4"/>
-          <p:cNvSpPr txBox="1"/>
-          <p:nvPr/>
-        </p:nvSpPr>
-        <p:spPr>
-          <a:xfrm>
-            <a:off x="357187" y="803671"/>
-            <a:ext cx="8429625" cy="267890"/>
-          </a:xfrm>
-          <a:prstGeom prst="rect">
-            <a:avLst/>
-          </a:prstGeom>
-          <a:noFill/>
-        </p:spPr>
-        <p:txBody>
-          <a:bodyPr wrap="square" tIns="0" bIns="0" lIns="0" rIns="0">
-            <a:spAutoFit/>
-          </a:bodyPr>
-          <a:lstStyle/>
-          <a:p>
-            <a:pPr algn="l">
-              <a:lnSpc>
-                <a:spcPct val="120000"/>
-              </a:lnSpc>
-              <a:defRPr sz="1500" b="0" i="0">
-                <a:solidFill>
-                  <a:srgbClr val="6D8470"/>
-                </a:solidFill>
-                <a:latin typeface="Arimo"/>
-              </a:defRPr>
-            </a:pPr>
-            <a:r>
-              <a:rPr sz="1500" b="0" i="0">
-                <a:solidFill>
-                  <a:srgbClr val="6D8470"/>
-                </a:solidFill>
-                <a:latin typeface="Arimo"/>
-              </a:rPr>
-              <a:t>Правила проведения химических пилингов и защита кожи</a:t>
-            </a:r>
-          </a:p>
-        </p:txBody>
-      </p:sp>
-      <p:sp>
-        <p:nvSpPr>
-          <p:cNvPr id="6" name="Rounded Rectangle 5"/>
+          <p:cNvPr id="4" name="Rectangle 3"/>
           <p:cNvSpPr/>
           <p:nvPr/>
         </p:nvSpPr>
         <p:spPr>
           <a:xfrm>
-            <a:off x="357187" y="1339453"/>
-            <a:ext cx="8430768" cy="2496312"/>
-          </a:xfrm>
-          <a:prstGeom prst="roundRect">
+            <a:off x="357187" y="4732734"/>
+            <a:ext cx="8429625" cy="8929"/>
+          </a:xfrm>
+          <a:prstGeom prst="rect">
             <a:avLst/>
           </a:prstGeom>
           <a:solidFill>
-            <a:srgbClr val="E6D2CA"/>
+            <a:srgbClr val="D7E0CE"/>
           </a:solidFill>
-          <a:ln w="25400">
-            <a:solidFill>
-              <a:srgbClr val="9E6A5A"/>
-            </a:solidFill>
+          <a:ln>
+            <a:noFill/>
           </a:ln>
         </p:spPr>
         <p:style>
@@ -5101,9 +5528,258 @@
           </a:p>
         </p:txBody>
       </p:sp>
+      <p:pic>
+        <p:nvPicPr>
+          <p:cNvPr id="5" name="Picture 4" descr="mark_6D8470.png"/>
+          <p:cNvPicPr>
+            <a:picLocks noChangeAspect="1"/>
+          </p:cNvPicPr>
+          <p:nvPr/>
+        </p:nvPicPr>
+        <p:blipFill>
+          <a:blip r:embed="rId2"/>
+          <a:stretch>
+            <a:fillRect/>
+          </a:stretch>
+        </p:blipFill>
+        <p:spPr>
+          <a:xfrm>
+            <a:off x="357187" y="4848820"/>
+            <a:ext cx="178593" cy="178593"/>
+          </a:xfrm>
+          <a:prstGeom prst="rect">
+            <a:avLst/>
+          </a:prstGeom>
+        </p:spPr>
+      </p:pic>
+      <p:sp>
+        <p:nvSpPr>
+          <p:cNvPr id="6" name="TextBox 5"/>
+          <p:cNvSpPr txBox="1"/>
+          <p:nvPr/>
+        </p:nvSpPr>
+        <p:spPr>
+          <a:xfrm>
+            <a:off x="607218" y="4830960"/>
+            <a:ext cx="1785937" cy="178593"/>
+          </a:xfrm>
+          <a:prstGeom prst="rect">
+            <a:avLst/>
+          </a:prstGeom>
+          <a:noFill/>
+        </p:spPr>
+        <p:txBody>
+          <a:bodyPr wrap="square" tIns="0" bIns="0" lIns="0" rIns="0">
+            <a:spAutoFit/>
+          </a:bodyPr>
+          <a:lstStyle/>
+          <a:p>
+            <a:pPr algn="l">
+              <a:lnSpc>
+                <a:spcPct val="120000"/>
+              </a:lnSpc>
+              <a:defRPr sz="1100" b="1" i="0">
+                <a:solidFill>
+                  <a:srgbClr val="3D4A40"/>
+                </a:solidFill>
+                <a:latin typeface="Arimo"/>
+              </a:defRPr>
+            </a:pPr>
+            <a:r>
+              <a:rPr sz="1100" b="1" i="0">
+                <a:solidFill>
+                  <a:srgbClr val="3D4A40"/>
+                </a:solidFill>
+                <a:latin typeface="Arimo"/>
+              </a:rPr>
+              <a:t>YM PROSKIN</a:t>
+            </a:r>
+          </a:p>
+        </p:txBody>
+      </p:sp>
       <p:sp>
         <p:nvSpPr>
           <p:cNvPr id="7" name="TextBox 6"/>
+          <p:cNvSpPr txBox="1"/>
+          <p:nvPr/>
+        </p:nvSpPr>
+        <p:spPr>
+          <a:xfrm>
+            <a:off x="8251031" y="4830960"/>
+            <a:ext cx="535781" cy="178593"/>
+          </a:xfrm>
+          <a:prstGeom prst="rect">
+            <a:avLst/>
+          </a:prstGeom>
+          <a:noFill/>
+        </p:spPr>
+        <p:txBody>
+          <a:bodyPr wrap="square" tIns="0" bIns="0" lIns="0" rIns="0">
+            <a:spAutoFit/>
+          </a:bodyPr>
+          <a:lstStyle/>
+          <a:p>
+            <a:pPr algn="r">
+              <a:lnSpc>
+                <a:spcPct val="120000"/>
+              </a:lnSpc>
+              <a:defRPr sz="1100" b="0" i="0">
+                <a:solidFill>
+                  <a:srgbClr val="6D8470"/>
+                </a:solidFill>
+                <a:latin typeface="Arimo"/>
+              </a:defRPr>
+            </a:pPr>
+            <a:r>
+              <a:rPr sz="1100" b="0" i="0">
+                <a:solidFill>
+                  <a:srgbClr val="6D8470"/>
+                </a:solidFill>
+                <a:latin typeface="Arimo"/>
+              </a:rPr>
+              <a:t>6</a:t>
+            </a:r>
+          </a:p>
+        </p:txBody>
+      </p:sp>
+      <p:sp>
+        <p:nvSpPr>
+          <p:cNvPr id="8" name="TextBox 7"/>
+          <p:cNvSpPr txBox="1"/>
+          <p:nvPr/>
+        </p:nvSpPr>
+        <p:spPr>
+          <a:xfrm>
+            <a:off x="357187" y="357187"/>
+            <a:ext cx="8429625" cy="401835"/>
+          </a:xfrm>
+          <a:prstGeom prst="rect">
+            <a:avLst/>
+          </a:prstGeom>
+          <a:noFill/>
+        </p:spPr>
+        <p:txBody>
+          <a:bodyPr wrap="square" tIns="0" bIns="0" lIns="0" rIns="0">
+            <a:spAutoFit/>
+          </a:bodyPr>
+          <a:lstStyle/>
+          <a:p>
+            <a:pPr algn="l">
+              <a:lnSpc>
+                <a:spcPct val="120000"/>
+              </a:lnSpc>
+              <a:defRPr sz="2600" b="1" i="0">
+                <a:solidFill>
+                  <a:srgbClr val="2C3440"/>
+                </a:solidFill>
+                <a:latin typeface="Arimo"/>
+              </a:defRPr>
+            </a:pPr>
+            <a:r>
+              <a:rPr sz="2600" b="1" i="0">
+                <a:solidFill>
+                  <a:srgbClr val="2C3440"/>
+                </a:solidFill>
+                <a:latin typeface="Arimo"/>
+              </a:rPr>
+              <a:t>Меры Предосторожности</a:t>
+            </a:r>
+          </a:p>
+        </p:txBody>
+      </p:sp>
+      <p:sp>
+        <p:nvSpPr>
+          <p:cNvPr id="9" name="TextBox 8"/>
+          <p:cNvSpPr txBox="1"/>
+          <p:nvPr/>
+        </p:nvSpPr>
+        <p:spPr>
+          <a:xfrm>
+            <a:off x="357187" y="803671"/>
+            <a:ext cx="8429625" cy="267890"/>
+          </a:xfrm>
+          <a:prstGeom prst="rect">
+            <a:avLst/>
+          </a:prstGeom>
+          <a:noFill/>
+        </p:spPr>
+        <p:txBody>
+          <a:bodyPr wrap="square" tIns="0" bIns="0" lIns="0" rIns="0">
+            <a:spAutoFit/>
+          </a:bodyPr>
+          <a:lstStyle/>
+          <a:p>
+            <a:pPr algn="l">
+              <a:lnSpc>
+                <a:spcPct val="120000"/>
+              </a:lnSpc>
+              <a:defRPr sz="1500" b="0" i="0">
+                <a:solidFill>
+                  <a:srgbClr val="6D8470"/>
+                </a:solidFill>
+                <a:latin typeface="Arimo"/>
+              </a:defRPr>
+            </a:pPr>
+            <a:r>
+              <a:rPr sz="1500" b="0" i="0">
+                <a:solidFill>
+                  <a:srgbClr val="6D8470"/>
+                </a:solidFill>
+                <a:latin typeface="Arimo"/>
+              </a:rPr>
+              <a:t>Правила проведения химических пилингов и защита кожи</a:t>
+            </a:r>
+          </a:p>
+        </p:txBody>
+      </p:sp>
+      <p:sp>
+        <p:nvSpPr>
+          <p:cNvPr id="10" name="Rounded Rectangle 9"/>
+          <p:cNvSpPr/>
+          <p:nvPr/>
+        </p:nvSpPr>
+        <p:spPr>
+          <a:xfrm>
+            <a:off x="357187" y="1339453"/>
+            <a:ext cx="8430768" cy="2496312"/>
+          </a:xfrm>
+          <a:prstGeom prst="roundRect">
+            <a:avLst/>
+          </a:prstGeom>
+          <a:solidFill>
+            <a:srgbClr val="E6D2CA"/>
+          </a:solidFill>
+          <a:ln w="25400">
+            <a:solidFill>
+              <a:srgbClr val="9E6A5A"/>
+            </a:solidFill>
+          </a:ln>
+        </p:spPr>
+        <p:style>
+          <a:lnRef idx="1">
+            <a:schemeClr val="accent1"/>
+          </a:lnRef>
+          <a:fillRef idx="3">
+            <a:schemeClr val="accent1"/>
+          </a:fillRef>
+          <a:effectRef idx="2">
+            <a:schemeClr val="accent1"/>
+          </a:effectRef>
+          <a:fontRef idx="minor">
+            <a:schemeClr val="lt1"/>
+          </a:fontRef>
+        </p:style>
+        <p:txBody>
+          <a:bodyPr rtlCol="0" anchor="ctr"/>
+          <a:lstStyle/>
+          <a:p>
+            <a:pPr algn="ctr"/>
+          </a:p>
+        </p:txBody>
+      </p:sp>
+      <p:sp>
+        <p:nvSpPr>
+          <p:cNvPr id="11" name="TextBox 10"/>
           <p:cNvSpPr txBox="1"/>
           <p:nvPr/>
         </p:nvSpPr>
@@ -5148,7 +5824,7 @@
       </p:sp>
       <p:sp>
         <p:nvSpPr>
-          <p:cNvPr id="8" name="TextBox 7"/>
+          <p:cNvPr id="12" name="TextBox 11"/>
           <p:cNvSpPr txBox="1"/>
           <p:nvPr/>
         </p:nvSpPr>
@@ -5193,7 +5869,7 @@
       </p:sp>
       <p:sp>
         <p:nvSpPr>
-          <p:cNvPr id="9" name="TextBox 8"/>
+          <p:cNvPr id="13" name="TextBox 12"/>
           <p:cNvSpPr txBox="1"/>
           <p:nvPr/>
         </p:nvSpPr>
@@ -5270,7 +5946,7 @@
         </p:nvSpPr>
         <p:spPr>
           <a:xfrm>
-            <a:off x="357187" y="4643437"/>
+            <a:off x="357187" y="4464843"/>
             <a:ext cx="4572000" cy="274320"/>
           </a:xfrm>
           <a:prstGeom prst="rect">
@@ -5315,7 +5991,7 @@
         </p:nvSpPr>
         <p:spPr>
           <a:xfrm>
-            <a:off x="5029200" y="4643437"/>
+            <a:off x="5029200" y="4464843"/>
             <a:ext cx="3749039" cy="274320"/>
           </a:xfrm>
           <a:prstGeom prst="rect">
@@ -5354,115 +6030,23 @@
       </p:sp>
       <p:sp>
         <p:nvSpPr>
-          <p:cNvPr id="4" name="TextBox 3"/>
-          <p:cNvSpPr txBox="1"/>
-          <p:nvPr/>
-        </p:nvSpPr>
-        <p:spPr>
-          <a:xfrm>
-            <a:off x="357187" y="357187"/>
-            <a:ext cx="8429625" cy="401835"/>
-          </a:xfrm>
-          <a:prstGeom prst="rect">
-            <a:avLst/>
-          </a:prstGeom>
-          <a:noFill/>
-        </p:spPr>
-        <p:txBody>
-          <a:bodyPr wrap="square" tIns="0" bIns="0" lIns="0" rIns="0">
-            <a:spAutoFit/>
-          </a:bodyPr>
-          <a:lstStyle/>
-          <a:p>
-            <a:pPr algn="l">
-              <a:lnSpc>
-                <a:spcPct val="120000"/>
-              </a:lnSpc>
-              <a:defRPr sz="2600" b="1" i="0">
-                <a:solidFill>
-                  <a:srgbClr val="2C3440"/>
-                </a:solidFill>
-                <a:latin typeface="Arimo"/>
-              </a:defRPr>
-            </a:pPr>
-            <a:r>
-              <a:rPr sz="2600" b="1" i="0">
-                <a:solidFill>
-                  <a:srgbClr val="2C3440"/>
-                </a:solidFill>
-                <a:latin typeface="Arimo"/>
-              </a:rPr>
-              <a:t>Терапевтические выводы</a:t>
-            </a:r>
-          </a:p>
-        </p:txBody>
-      </p:sp>
-      <p:sp>
-        <p:nvSpPr>
-          <p:cNvPr id="5" name="TextBox 4"/>
-          <p:cNvSpPr txBox="1"/>
-          <p:nvPr/>
-        </p:nvSpPr>
-        <p:spPr>
-          <a:xfrm>
-            <a:off x="357187" y="803671"/>
-            <a:ext cx="8429625" cy="267890"/>
-          </a:xfrm>
-          <a:prstGeom prst="rect">
-            <a:avLst/>
-          </a:prstGeom>
-          <a:noFill/>
-        </p:spPr>
-        <p:txBody>
-          <a:bodyPr wrap="square" tIns="0" bIns="0" lIns="0" rIns="0">
-            <a:spAutoFit/>
-          </a:bodyPr>
-          <a:lstStyle/>
-          <a:p>
-            <a:pPr algn="l">
-              <a:lnSpc>
-                <a:spcPct val="120000"/>
-              </a:lnSpc>
-              <a:defRPr sz="1500" b="0" i="0">
-                <a:solidFill>
-                  <a:srgbClr val="6D8470"/>
-                </a:solidFill>
-                <a:latin typeface="Arimo"/>
-              </a:defRPr>
-            </a:pPr>
-            <a:r>
-              <a:rPr sz="1500" b="0" i="0">
-                <a:solidFill>
-                  <a:srgbClr val="6D8470"/>
-                </a:solidFill>
-                <a:latin typeface="Arimo"/>
-              </a:rPr>
-              <a:t>Резюме по клиническому применению гидроксикислот</a:t>
-            </a:r>
-          </a:p>
-        </p:txBody>
-      </p:sp>
-      <p:sp>
-        <p:nvSpPr>
-          <p:cNvPr id="6" name="Rounded Rectangle 5"/>
+          <p:cNvPr id="4" name="Rectangle 3"/>
           <p:cNvSpPr/>
           <p:nvPr/>
         </p:nvSpPr>
         <p:spPr>
           <a:xfrm>
-            <a:off x="357187" y="1303734"/>
-            <a:ext cx="8430768" cy="2857500"/>
-          </a:xfrm>
-          <a:prstGeom prst="roundRect">
+            <a:off x="357187" y="4732734"/>
+            <a:ext cx="8429625" cy="8929"/>
+          </a:xfrm>
+          <a:prstGeom prst="rect">
             <a:avLst/>
           </a:prstGeom>
           <a:solidFill>
-            <a:srgbClr val="E6D2CA"/>
+            <a:srgbClr val="D7E0CE"/>
           </a:solidFill>
-          <a:ln w="12700">
-            <a:solidFill>
-              <a:srgbClr val="D7E0CE"/>
-            </a:solidFill>
+          <a:ln>
+            <a:noFill/>
           </a:ln>
         </p:spPr>
         <p:style>
@@ -5487,6 +6071,75 @@
           </a:p>
         </p:txBody>
       </p:sp>
+      <p:pic>
+        <p:nvPicPr>
+          <p:cNvPr id="5" name="Picture 4" descr="mark_6D8470.png"/>
+          <p:cNvPicPr>
+            <a:picLocks noChangeAspect="1"/>
+          </p:cNvPicPr>
+          <p:nvPr/>
+        </p:nvPicPr>
+        <p:blipFill>
+          <a:blip r:embed="rId2"/>
+          <a:stretch>
+            <a:fillRect/>
+          </a:stretch>
+        </p:blipFill>
+        <p:spPr>
+          <a:xfrm>
+            <a:off x="357187" y="4848820"/>
+            <a:ext cx="178593" cy="178593"/>
+          </a:xfrm>
+          <a:prstGeom prst="rect">
+            <a:avLst/>
+          </a:prstGeom>
+        </p:spPr>
+      </p:pic>
+      <p:sp>
+        <p:nvSpPr>
+          <p:cNvPr id="6" name="TextBox 5"/>
+          <p:cNvSpPr txBox="1"/>
+          <p:nvPr/>
+        </p:nvSpPr>
+        <p:spPr>
+          <a:xfrm>
+            <a:off x="607218" y="4830960"/>
+            <a:ext cx="1785937" cy="178593"/>
+          </a:xfrm>
+          <a:prstGeom prst="rect">
+            <a:avLst/>
+          </a:prstGeom>
+          <a:noFill/>
+        </p:spPr>
+        <p:txBody>
+          <a:bodyPr wrap="square" tIns="0" bIns="0" lIns="0" rIns="0">
+            <a:spAutoFit/>
+          </a:bodyPr>
+          <a:lstStyle/>
+          <a:p>
+            <a:pPr algn="l">
+              <a:lnSpc>
+                <a:spcPct val="120000"/>
+              </a:lnSpc>
+              <a:defRPr sz="1100" b="1" i="0">
+                <a:solidFill>
+                  <a:srgbClr val="3D4A40"/>
+                </a:solidFill>
+                <a:latin typeface="Arimo"/>
+              </a:defRPr>
+            </a:pPr>
+            <a:r>
+              <a:rPr sz="1100" b="1" i="0">
+                <a:solidFill>
+                  <a:srgbClr val="3D4A40"/>
+                </a:solidFill>
+                <a:latin typeface="Arimo"/>
+              </a:rPr>
+              <a:t>YM PROSKIN</a:t>
+            </a:r>
+          </a:p>
+        </p:txBody>
+      </p:sp>
       <p:sp>
         <p:nvSpPr>
           <p:cNvPr id="7" name="TextBox 6"/>
@@ -5495,8 +6148,98 @@
         </p:nvSpPr>
         <p:spPr>
           <a:xfrm>
-            <a:off x="640080" y="1580554"/>
-            <a:ext cx="7863840" cy="2286000"/>
+            <a:off x="8251031" y="4830960"/>
+            <a:ext cx="535781" cy="178593"/>
+          </a:xfrm>
+          <a:prstGeom prst="rect">
+            <a:avLst/>
+          </a:prstGeom>
+          <a:noFill/>
+        </p:spPr>
+        <p:txBody>
+          <a:bodyPr wrap="square" tIns="0" bIns="0" lIns="0" rIns="0">
+            <a:spAutoFit/>
+          </a:bodyPr>
+          <a:lstStyle/>
+          <a:p>
+            <a:pPr algn="r">
+              <a:lnSpc>
+                <a:spcPct val="120000"/>
+              </a:lnSpc>
+              <a:defRPr sz="1100" b="0" i="0">
+                <a:solidFill>
+                  <a:srgbClr val="6D8470"/>
+                </a:solidFill>
+                <a:latin typeface="Arimo"/>
+              </a:defRPr>
+            </a:pPr>
+            <a:r>
+              <a:rPr sz="1100" b="0" i="0">
+                <a:solidFill>
+                  <a:srgbClr val="6D8470"/>
+                </a:solidFill>
+                <a:latin typeface="Arimo"/>
+              </a:rPr>
+              <a:t>7</a:t>
+            </a:r>
+          </a:p>
+        </p:txBody>
+      </p:sp>
+      <p:sp>
+        <p:nvSpPr>
+          <p:cNvPr id="8" name="TextBox 7"/>
+          <p:cNvSpPr txBox="1"/>
+          <p:nvPr/>
+        </p:nvSpPr>
+        <p:spPr>
+          <a:xfrm>
+            <a:off x="357187" y="357187"/>
+            <a:ext cx="8429625" cy="401835"/>
+          </a:xfrm>
+          <a:prstGeom prst="rect">
+            <a:avLst/>
+          </a:prstGeom>
+          <a:noFill/>
+        </p:spPr>
+        <p:txBody>
+          <a:bodyPr wrap="square" tIns="0" bIns="0" lIns="0" rIns="0">
+            <a:spAutoFit/>
+          </a:bodyPr>
+          <a:lstStyle/>
+          <a:p>
+            <a:pPr algn="l">
+              <a:lnSpc>
+                <a:spcPct val="120000"/>
+              </a:lnSpc>
+              <a:defRPr sz="2600" b="1" i="0">
+                <a:solidFill>
+                  <a:srgbClr val="2C3440"/>
+                </a:solidFill>
+                <a:latin typeface="Arimo"/>
+              </a:defRPr>
+            </a:pPr>
+            <a:r>
+              <a:rPr sz="2600" b="1" i="0">
+                <a:solidFill>
+                  <a:srgbClr val="2C3440"/>
+                </a:solidFill>
+                <a:latin typeface="Arimo"/>
+              </a:rPr>
+              <a:t>Терапевтические выводы</a:t>
+            </a:r>
+          </a:p>
+        </p:txBody>
+      </p:sp>
+      <p:sp>
+        <p:nvSpPr>
+          <p:cNvPr id="9" name="TextBox 8"/>
+          <p:cNvSpPr txBox="1"/>
+          <p:nvPr/>
+        </p:nvSpPr>
+        <p:spPr>
+          <a:xfrm>
+            <a:off x="357187" y="803671"/>
+            <a:ext cx="8429625" cy="267890"/>
           </a:xfrm>
           <a:prstGeom prst="rect">
             <a:avLst/>
@@ -5515,7 +6258,7 @@
               </a:lnSpc>
               <a:defRPr sz="1500" b="0" i="0">
                 <a:solidFill>
-                  <a:srgbClr val="3D4A40"/>
+                  <a:srgbClr val="6D8470"/>
                 </a:solidFill>
                 <a:latin typeface="Arimo"/>
               </a:defRPr>
@@ -5523,13 +6266,81 @@
             <a:r>
               <a:rPr sz="1500" b="0" i="0">
                 <a:solidFill>
-                  <a:srgbClr val="3D4A40"/>
+                  <a:srgbClr val="6D8470"/>
                 </a:solidFill>
                 <a:latin typeface="Arimo"/>
               </a:rPr>
-              <a:t>• Салициловая кислота — золотой стандарт комедолиза и эксфолиации за счет десмолитического действия.</a:t>
-            </a:r>
-          </a:p>
+              <a:t>Резюме по клиническому применению гидроксикислот</a:t>
+            </a:r>
+          </a:p>
+        </p:txBody>
+      </p:sp>
+      <p:sp>
+        <p:nvSpPr>
+          <p:cNvPr id="10" name="Rounded Rectangle 9"/>
+          <p:cNvSpPr/>
+          <p:nvPr/>
+        </p:nvSpPr>
+        <p:spPr>
+          <a:xfrm>
+            <a:off x="357187" y="1303734"/>
+            <a:ext cx="8430768" cy="2857500"/>
+          </a:xfrm>
+          <a:prstGeom prst="roundRect">
+            <a:avLst/>
+          </a:prstGeom>
+          <a:solidFill>
+            <a:srgbClr val="E6D2CA"/>
+          </a:solidFill>
+          <a:ln w="12700">
+            <a:solidFill>
+              <a:srgbClr val="D7E0CE"/>
+            </a:solidFill>
+          </a:ln>
+        </p:spPr>
+        <p:style>
+          <a:lnRef idx="1">
+            <a:schemeClr val="accent1"/>
+          </a:lnRef>
+          <a:fillRef idx="3">
+            <a:schemeClr val="accent1"/>
+          </a:fillRef>
+          <a:effectRef idx="2">
+            <a:schemeClr val="accent1"/>
+          </a:effectRef>
+          <a:fontRef idx="minor">
+            <a:schemeClr val="lt1"/>
+          </a:fontRef>
+        </p:style>
+        <p:txBody>
+          <a:bodyPr rtlCol="0" anchor="ctr"/>
+          <a:lstStyle/>
+          <a:p>
+            <a:pPr algn="ctr"/>
+          </a:p>
+        </p:txBody>
+      </p:sp>
+      <p:sp>
+        <p:nvSpPr>
+          <p:cNvPr id="11" name="TextBox 10"/>
+          <p:cNvSpPr txBox="1"/>
+          <p:nvPr/>
+        </p:nvSpPr>
+        <p:spPr>
+          <a:xfrm>
+            <a:off x="640080" y="1580554"/>
+            <a:ext cx="7863840" cy="2286000"/>
+          </a:xfrm>
+          <a:prstGeom prst="rect">
+            <a:avLst/>
+          </a:prstGeom>
+          <a:noFill/>
+        </p:spPr>
+        <p:txBody>
+          <a:bodyPr wrap="square" tIns="0" bIns="0" lIns="0" rIns="0">
+            <a:spAutoFit/>
+          </a:bodyPr>
+          <a:lstStyle/>
           <a:p>
             <a:pPr algn="l">
               <a:lnSpc>
@@ -5542,6 +6353,15 @@
                 <a:latin typeface="Arimo"/>
               </a:defRPr>
             </a:pPr>
+            <a:r>
+              <a:rPr sz="1500" b="0" i="0">
+                <a:solidFill>
+                  <a:srgbClr val="3D4A40"/>
+                </a:solidFill>
+                <a:latin typeface="Arimo"/>
+              </a:rPr>
+              <a:t>• Салициловая кислота — золотой стандарт комедолиза и эксфолиации за счет десмолитического действия.</a:t>
+            </a:r>
           </a:p>
           <a:p>
             <a:pPr algn="l">
@@ -5555,15 +6375,6 @@
                 <a:latin typeface="Arimo"/>
               </a:defRPr>
             </a:pPr>
-            <a:r>
-              <a:rPr sz="1500" b="0" i="0">
-                <a:solidFill>
-                  <a:srgbClr val="3D4A40"/>
-                </a:solidFill>
-                <a:latin typeface="Arimo"/>
-              </a:rPr>
-              <a:t>• AHA и BHA пилинги высокой концентрации эффективно корректируют фотостарение и акне легкой/средней степени.</a:t>
-            </a:r>
           </a:p>
           <a:p>
             <a:pPr algn="l">
@@ -5577,6 +6388,15 @@
                 <a:latin typeface="Arimo"/>
               </a:defRPr>
             </a:pPr>
+            <a:r>
+              <a:rPr sz="1500" b="0" i="0">
+                <a:solidFill>
+                  <a:srgbClr val="3D4A40"/>
+                </a:solidFill>
+                <a:latin typeface="Arimo"/>
+              </a:rPr>
+              <a:t>• AHA и BHA пилинги высокой концентрации эффективно корректируют фотостарение и акне легкой/средней степени.</a:t>
+            </a:r>
           </a:p>
           <a:p>
             <a:pPr algn="l">
@@ -5590,6 +6410,19 @@
                 <a:latin typeface="Arimo"/>
               </a:defRPr>
             </a:pPr>
+          </a:p>
+          <a:p>
+            <a:pPr algn="l">
+              <a:lnSpc>
+                <a:spcPct val="120000"/>
+              </a:lnSpc>
+              <a:defRPr sz="1500" b="0" i="0">
+                <a:solidFill>
+                  <a:srgbClr val="3D4A40"/>
+                </a:solidFill>
+                <a:latin typeface="Arimo"/>
+              </a:defRPr>
+            </a:pPr>
             <a:r>
               <a:rPr sz="1500" b="0" i="0">
                 <a:solidFill>
@@ -5602,6 +6435,30 @@
           </a:p>
         </p:txBody>
       </p:sp>
+      <p:pic>
+        <p:nvPicPr>
+          <p:cNvPr id="12" name="Picture 11" descr="badge_2C3440.png"/>
+          <p:cNvPicPr>
+            <a:picLocks noChangeAspect="1"/>
+          </p:cNvPicPr>
+          <p:nvPr/>
+        </p:nvPicPr>
+        <p:blipFill>
+          <a:blip r:embed="rId3"/>
+          <a:stretch>
+            <a:fillRect/>
+          </a:stretch>
+        </p:blipFill>
+        <p:spPr>
+          <a:xfrm>
+            <a:off x="3750468" y="1750218"/>
+            <a:ext cx="1643062" cy="1643062"/>
+          </a:xfrm>
+          <a:prstGeom prst="rect">
+            <a:avLst/>
+          </a:prstGeom>
+        </p:spPr>
+      </p:pic>
     </p:spTree>
   </p:cSld>
   <p:clrMapOvr>

</xml_diff>